<commit_message>
apresentação em pdf e pptx atualizada
</commit_message>
<xml_diff>
--- a/assets/apresentacao.pptx
+++ b/assets/apresentacao.pptx
@@ -3556,7 +3556,7 @@
                 <a:cs typeface="Genty"/>
                 <a:sym typeface="Genty"/>
               </a:rPr>
-              <a:t>A Ideia e a Otimização de UX</a:t>
+              <a:t>A Ideia e o Diferencial</a:t>
             </a:r>
           </a:p>
         </p:txBody>
@@ -4514,7 +4514,7 @@
         </p:nvSpPr>
         <p:spPr>
           <a:xfrm rot="0">
-            <a:off x="620324" y="1063845"/>
+            <a:off x="1208346" y="958569"/>
             <a:ext cx="17281806" cy="1377949"/>
           </a:xfrm>
           <a:prstGeom prst="rect">
@@ -4542,7 +4542,7 @@
                 <a:cs typeface="Genty"/>
                 <a:sym typeface="Genty"/>
               </a:rPr>
-              <a:t>O Fluxo Inicial (O Primeiro Arranque)</a:t>
+              <a:t>O Fluxo Inicial </a:t>
             </a:r>
           </a:p>
         </p:txBody>
@@ -4608,7 +4608,7 @@
         <p:spPr>
           <a:xfrm rot="0">
             <a:off x="1208346" y="2892425"/>
-            <a:ext cx="9067288" cy="5832475"/>
+            <a:ext cx="9067288" cy="6365875"/>
           </a:xfrm>
           <a:prstGeom prst="rect">
             <a:avLst/>
@@ -4665,6 +4665,13 @@
             </a:r>
           </a:p>
           <a:p>
+            <a:pPr algn="l">
+              <a:lnSpc>
+                <a:spcPts val="4249"/>
+              </a:lnSpc>
+            </a:pPr>
+          </a:p>
+          <a:p>
             <a:pPr algn="l" marL="539749" indent="-269875" lvl="1">
               <a:lnSpc>
                 <a:spcPts val="4249"/>
@@ -4698,6 +4705,13 @@
             </a:r>
           </a:p>
           <a:p>
+            <a:pPr algn="l">
+              <a:lnSpc>
+                <a:spcPts val="4249"/>
+              </a:lnSpc>
+            </a:pPr>
+          </a:p>
+          <a:p>
             <a:pPr algn="l" marL="539749" indent="-269875" lvl="1">
               <a:lnSpc>
                 <a:spcPts val="4249"/>
@@ -4743,25 +4757,11 @@
             </a:r>
           </a:p>
           <a:p>
-            <a:pPr algn="l" marL="1079499" indent="-359833" lvl="2">
+            <a:pPr algn="l">
               <a:lnSpc>
                 <a:spcPts val="4249"/>
               </a:lnSpc>
-              <a:buFont typeface="Arial"/>
-              <a:buChar char="⚬"/>
             </a:pPr>
-            <a:r>
-              <a:rPr lang="en-US" sz="2499">
-                <a:solidFill>
-                  <a:srgbClr val="503530"/>
-                </a:solidFill>
-                <a:latin typeface="Open Sauce"/>
-                <a:ea typeface="Open Sauce"/>
-                <a:cs typeface="Open Sauce"/>
-                <a:sym typeface="Open Sauce"/>
-              </a:rPr>
-              <a:t>Usa o símbolo = para atribuição correta de variáveis.</a:t>
-            </a:r>
           </a:p>
           <a:p>
             <a:pPr algn="l">
@@ -4885,30 +4885,6 @@
               <a:buChar char="•"/>
             </a:pPr>
             <a:r>
-              <a:rPr lang="en-US" b="true" sz="2499">
-                <a:solidFill>
-                  <a:srgbClr val="381F1B"/>
-                </a:solidFill>
-                <a:latin typeface="Open Sauce Bold"/>
-                <a:ea typeface="Open Sauce Bold"/>
-                <a:cs typeface="Open Sauce Bold"/>
-                <a:sym typeface="Open Sauce Bold"/>
-              </a:rPr>
-              <a:t>O qu</a:t>
-            </a:r>
-            <a:r>
-              <a:rPr lang="en-US" b="true" sz="2499">
-                <a:solidFill>
-                  <a:srgbClr val="381F1B"/>
-                </a:solidFill>
-                <a:latin typeface="Open Sauce Bold"/>
-                <a:ea typeface="Open Sauce Bold"/>
-                <a:cs typeface="Open Sauce Bold"/>
-                <a:sym typeface="Open Sauce Bold"/>
-              </a:rPr>
-              <a:t>e acontece no ecrã: </a:t>
-            </a:r>
-            <a:r>
               <a:rPr lang="en-US" sz="2499">
                 <a:solidFill>
                   <a:srgbClr val="381F1B"/>
@@ -4970,19 +4946,7 @@
                 <a:cs typeface="Open Sauce Bold"/>
                 <a:sym typeface="Open Sauce Bold"/>
               </a:rPr>
-              <a:t>Demonstra</a:t>
-            </a:r>
-            <a:r>
-              <a:rPr lang="en-US" b="true" sz="2499">
-                <a:solidFill>
-                  <a:srgbClr val="381F1B"/>
-                </a:solidFill>
-                <a:latin typeface="Open Sauce Bold"/>
-                <a:ea typeface="Open Sauce Bold"/>
-                <a:cs typeface="Open Sauce Bold"/>
-                <a:sym typeface="Open Sauce Bold"/>
-              </a:rPr>
-              <a:t>ção do Código:</a:t>
+              <a:t>Exemplo:</a:t>
             </a:r>
           </a:p>
           <a:p>
@@ -5181,7 +5145,7 @@
                 <a:cs typeface="Genty"/>
                 <a:sym typeface="Genty"/>
               </a:rPr>
-              <a:t>O Loop Diário e a Inteligência de UX </a:t>
+              <a:t>O Loop Diário  </a:t>
             </a:r>
           </a:p>
         </p:txBody>
@@ -5268,7 +5232,7 @@
         <p:spPr>
           <a:xfrm rot="0">
             <a:off x="1028700" y="3959225"/>
-            <a:ext cx="14932683" cy="5299075"/>
+            <a:ext cx="14932683" cy="5832475"/>
           </a:xfrm>
           <a:prstGeom prst="rect">
             <a:avLst/>
@@ -5290,7 +5254,7 @@
             <a:r>
               <a:rPr lang="en-US" b="true" sz="2499">
                 <a:solidFill>
-                  <a:srgbClr val="381F1B"/>
+                  <a:srgbClr val="503530"/>
                 </a:solidFill>
                 <a:latin typeface="Open Sauce Bold"/>
                 <a:ea typeface="Open Sauce Bold"/>
@@ -5302,7 +5266,7 @@
             <a:r>
               <a:rPr lang="en-US" b="true" sz="2499">
                 <a:solidFill>
-                  <a:srgbClr val="381F1B"/>
+                  <a:srgbClr val="503530"/>
                 </a:solidFill>
                 <a:latin typeface="Open Sauce Bold"/>
                 <a:ea typeface="Open Sauce Bold"/>
@@ -5314,7 +5278,7 @@
             <a:r>
               <a:rPr lang="en-US" sz="2499">
                 <a:solidFill>
-                  <a:srgbClr val="381F1B"/>
+                  <a:srgbClr val="503530"/>
                 </a:solidFill>
                 <a:latin typeface="Open Sauce"/>
                 <a:ea typeface="Open Sauce"/>
@@ -5335,7 +5299,7 @@
             <a:r>
               <a:rPr lang="en-US" sz="2499">
                 <a:solidFill>
-                  <a:srgbClr val="381F1B"/>
+                  <a:srgbClr val="503530"/>
                 </a:solidFill>
                 <a:latin typeface="Open Sauce"/>
                 <a:ea typeface="Open Sauce"/>
@@ -5347,7 +5311,7 @@
             <a:r>
               <a:rPr lang="en-US" sz="2499">
                 <a:solidFill>
-                  <a:srgbClr val="381F1B"/>
+                  <a:srgbClr val="503530"/>
                 </a:solidFill>
                 <a:latin typeface="Open Sauce"/>
                 <a:ea typeface="Open Sauce"/>
@@ -5368,7 +5332,7 @@
             <a:r>
               <a:rPr lang="en-US" sz="2499">
                 <a:solidFill>
-                  <a:srgbClr val="381F1B"/>
+                  <a:srgbClr val="503530"/>
                 </a:solidFill>
                 <a:latin typeface="Open Sauce"/>
                 <a:ea typeface="Open Sauce"/>
@@ -5380,14 +5344,14 @@
             <a:r>
               <a:rPr lang="en-US" sz="2499">
                 <a:solidFill>
-                  <a:srgbClr val="381F1B"/>
+                  <a:srgbClr val="503530"/>
                 </a:solidFill>
                 <a:latin typeface="Open Sauce"/>
                 <a:ea typeface="Open Sauce"/>
                 <a:cs typeface="Open Sauce"/>
                 <a:sym typeface="Open Sauce"/>
               </a:rPr>
-              <a:t> programa faz uma “varredura” estatística na lista de registos do JSON.</a:t>
+              <a:t> programa faz uma análise do histórico na lista de registos do JSON.</a:t>
             </a:r>
           </a:p>
           <a:p>
@@ -5401,7 +5365,7 @@
             <a:r>
               <a:rPr lang="en-US" sz="2499">
                 <a:solidFill>
-                  <a:srgbClr val="381F1B"/>
+                  <a:srgbClr val="503530"/>
                 </a:solidFill>
                 <a:latin typeface="Open Sauce"/>
                 <a:ea typeface="Open Sauce"/>
@@ -5413,7 +5377,7 @@
             <a:r>
               <a:rPr lang="en-US" sz="2499">
                 <a:solidFill>
-                  <a:srgbClr val="381F1B"/>
+                  <a:srgbClr val="503530"/>
                 </a:solidFill>
                 <a:latin typeface="Open Sauce"/>
                 <a:ea typeface="Open Sauce"/>
@@ -5422,6 +5386,13 @@
               </a:rPr>
               <a:t>o (if/elif).</a:t>
             </a:r>
+          </a:p>
+          <a:p>
+            <a:pPr algn="l">
+              <a:lnSpc>
+                <a:spcPts val="4249"/>
+              </a:lnSpc>
+            </a:pPr>
           </a:p>
           <a:p>
             <a:pPr algn="l" marL="539749" indent="-269875" lvl="1">
@@ -5434,7 +5405,7 @@
             <a:r>
               <a:rPr lang="en-US" b="true" sz="2499">
                 <a:solidFill>
-                  <a:srgbClr val="381F1B"/>
+                  <a:srgbClr val="503530"/>
                 </a:solidFill>
                 <a:latin typeface="Open Sauce Bold"/>
                 <a:ea typeface="Open Sauce Bold"/>
@@ -5455,7 +5426,7 @@
             <a:r>
               <a:rPr lang="en-US" b="true" sz="2499">
                 <a:solidFill>
-                  <a:srgbClr val="381F1B"/>
+                  <a:srgbClr val="503530"/>
                 </a:solidFill>
                 <a:latin typeface="Open Sauce Bold"/>
                 <a:ea typeface="Open Sauce Bold"/>
@@ -5467,7 +5438,7 @@
             <a:r>
               <a:rPr lang="en-US" sz="2499">
                 <a:solidFill>
-                  <a:srgbClr val="381F1B"/>
+                  <a:srgbClr val="503530"/>
                 </a:solidFill>
                 <a:latin typeface="Open Sauce"/>
                 <a:ea typeface="Open Sauce"/>
@@ -5488,7 +5459,7 @@
             <a:r>
               <a:rPr lang="en-US" b="true" sz="2499">
                 <a:solidFill>
-                  <a:srgbClr val="381F1B"/>
+                  <a:srgbClr val="503530"/>
                 </a:solidFill>
                 <a:latin typeface="Open Sauce Bold"/>
                 <a:ea typeface="Open Sauce Bold"/>
@@ -5500,7 +5471,7 @@
             <a:r>
               <a:rPr lang="en-US" sz="2499">
                 <a:solidFill>
-                  <a:srgbClr val="381F1B"/>
+                  <a:srgbClr val="503530"/>
                 </a:solidFill>
                 <a:latin typeface="Open Sauce"/>
                 <a:ea typeface="Open Sauce"/>
@@ -5521,7 +5492,7 @@
             <a:r>
               <a:rPr lang="en-US" b="true" sz="2499">
                 <a:solidFill>
-                  <a:srgbClr val="381F1B"/>
+                  <a:srgbClr val="503530"/>
                 </a:solidFill>
                 <a:latin typeface="Open Sauce Bold"/>
                 <a:ea typeface="Open Sauce Bold"/>
@@ -5533,7 +5504,7 @@
             <a:r>
               <a:rPr lang="en-US" b="true" sz="2499">
                 <a:solidFill>
-                  <a:srgbClr val="381F1B"/>
+                  <a:srgbClr val="503530"/>
                 </a:solidFill>
                 <a:latin typeface="Open Sauce Bold"/>
                 <a:ea typeface="Open Sauce Bold"/>
@@ -5545,7 +5516,7 @@
             <a:r>
               <a:rPr lang="en-US" sz="2499">
                 <a:solidFill>
-                  <a:srgbClr val="381F1B"/>
+                  <a:srgbClr val="503530"/>
                 </a:solidFill>
                 <a:latin typeface="Open Sauce"/>
                 <a:ea typeface="Open Sauce"/>
@@ -5600,7 +5571,7 @@
                 <a:cs typeface="Genty"/>
                 <a:sym typeface="Genty"/>
               </a:rPr>
-              <a:t>O Motor de Análise de Saúde e Alertas Visuais</a:t>
+              <a:t>Análise de Saúde e Alertas Visuais</a:t>
             </a:r>
           </a:p>
         </p:txBody>
@@ -5673,7 +5644,7 @@
                 <a:cs typeface="Genty"/>
                 <a:sym typeface="Genty"/>
               </a:rPr>
-              <a:t>Triagem e Recomendação Geográfica</a:t>
+              <a:t>Recomendação Geográfica</a:t>
             </a:r>
           </a:p>
         </p:txBody>
@@ -5687,7 +5658,7 @@
         <p:spPr>
           <a:xfrm rot="0">
             <a:off x="1234979" y="3555815"/>
-            <a:ext cx="14316183" cy="5832475"/>
+            <a:ext cx="14316183" cy="2632075"/>
           </a:xfrm>
           <a:prstGeom prst="rect">
             <a:avLst/>
@@ -5744,13 +5715,6 @@
             </a:r>
           </a:p>
           <a:p>
-            <a:pPr algn="l">
-              <a:lnSpc>
-                <a:spcPts val="4249"/>
-              </a:lnSpc>
-            </a:pPr>
-          </a:p>
-          <a:p>
             <a:pPr algn="l" marL="539749" indent="-269875" lvl="1">
               <a:lnSpc>
                 <a:spcPts val="4249"/>
@@ -5759,39 +5723,6 @@
               <a:buChar char="•"/>
             </a:pPr>
             <a:r>
-              <a:rPr lang="en-US" b="true" sz="2499">
-                <a:solidFill>
-                  <a:srgbClr val="503530"/>
-                </a:solidFill>
-                <a:latin typeface="Open Sauce Bold"/>
-                <a:ea typeface="Open Sauce Bold"/>
-                <a:cs typeface="Open Sauce Bold"/>
-                <a:sym typeface="Open Sauce Bold"/>
-              </a:rPr>
-              <a:t>R</a:t>
-            </a:r>
-            <a:r>
-              <a:rPr lang="en-US" b="true" sz="2499">
-                <a:solidFill>
-                  <a:srgbClr val="503530"/>
-                </a:solidFill>
-                <a:latin typeface="Open Sauce Bold"/>
-                <a:ea typeface="Open Sauce Bold"/>
-                <a:cs typeface="Open Sauce Bold"/>
-                <a:sym typeface="Open Sauce Bold"/>
-              </a:rPr>
-              <a:t>esolução do Bug Técnico (Multi-Especialidades):</a:t>
-            </a:r>
-          </a:p>
-          <a:p>
-            <a:pPr algn="l" marL="1079499" indent="-359833" lvl="2">
-              <a:lnSpc>
-                <a:spcPts val="4249"/>
-              </a:lnSpc>
-              <a:buFont typeface="Arial"/>
-              <a:buChar char="⚬"/>
-            </a:pPr>
-            <a:r>
               <a:rPr lang="en-US" sz="2499">
                 <a:solidFill>
                   <a:srgbClr val="503530"/>
@@ -5801,85 +5732,7 @@
                 <a:cs typeface="Open Sauce"/>
                 <a:sym typeface="Open Sauce"/>
               </a:rPr>
-              <a:t>D</a:t>
-            </a:r>
-            <a:r>
-              <a:rPr lang="en-US" sz="2499">
-                <a:solidFill>
-                  <a:srgbClr val="503530"/>
-                </a:solidFill>
-                <a:latin typeface="Open Sauce"/>
-                <a:ea typeface="Open Sauce"/>
-                <a:cs typeface="Open Sauce"/>
-                <a:sym typeface="Open Sauce"/>
-              </a:rPr>
-              <a:t>iagnóstico do Erro: "TypeError" ao tentar usar uma lista mutável c</a:t>
-            </a:r>
-            <a:r>
-              <a:rPr lang="en-US" sz="2499">
-                <a:solidFill>
-                  <a:srgbClr val="503530"/>
-                </a:solidFill>
-                <a:latin typeface="Open Sauce"/>
-                <a:ea typeface="Open Sauce"/>
-                <a:cs typeface="Open Sauce"/>
-                <a:sym typeface="Open Sauce"/>
-              </a:rPr>
-              <a:t>omo chave de dicionário.</a:t>
-            </a:r>
-          </a:p>
-          <a:p>
-            <a:pPr algn="l" marL="1079499" indent="-359833" lvl="2">
-              <a:lnSpc>
-                <a:spcPts val="4249"/>
-              </a:lnSpc>
-              <a:buFont typeface="Arial"/>
-              <a:buChar char="⚬"/>
-            </a:pPr>
-            <a:r>
-              <a:rPr lang="en-US" sz="2499">
-                <a:solidFill>
-                  <a:srgbClr val="503530"/>
-                </a:solidFill>
-                <a:latin typeface="Open Sauce"/>
-                <a:ea typeface="Open Sauce"/>
-                <a:cs typeface="Open Sauce"/>
-                <a:sym typeface="Open Sauce"/>
-              </a:rPr>
-              <a:t>Sol</a:t>
-            </a:r>
-            <a:r>
-              <a:rPr lang="en-US" sz="2499">
-                <a:solidFill>
-                  <a:srgbClr val="503530"/>
-                </a:solidFill>
-                <a:latin typeface="Open Sauce"/>
-                <a:ea typeface="Open Sauce"/>
-                <a:cs typeface="Open Sauce"/>
-                <a:sym typeface="Open Sauce"/>
-              </a:rPr>
-              <a:t>ução: Integração de um loop 'for' para iterar o conjunto (set) de especialidades e extrair os médicos um a um. </a:t>
-            </a:r>
-          </a:p>
-          <a:p>
-            <a:pPr algn="l" marL="1079499" indent="-359833" lvl="2">
-              <a:lnSpc>
-                <a:spcPts val="4249"/>
-              </a:lnSpc>
-              <a:buFont typeface="Arial"/>
-              <a:buChar char="⚬"/>
-            </a:pPr>
-            <a:r>
-              <a:rPr lang="en-US" sz="2499">
-                <a:solidFill>
-                  <a:srgbClr val="503530"/>
-                </a:solidFill>
-                <a:latin typeface="Open Sauce"/>
-                <a:ea typeface="Open Sauce"/>
-                <a:cs typeface="Open Sauce"/>
-                <a:sym typeface="Open Sauce"/>
-              </a:rPr>
-              <a:t>Localização anexada permanentemente ao perfil no JSON para evitar perguntas redundantes.</a:t>
+              <a:t>Localização anexada permanentemente ao perfil no JSON para evitar perguntas redundantes futuras.</a:t>
             </a:r>
           </a:p>
           <a:p>
@@ -6113,19 +5966,7 @@
                 <a:cs typeface="Open Sauce"/>
                 <a:sym typeface="Open Sauce"/>
               </a:rPr>
-              <a:t>da na experiência do utilizador, cuja arquitetura permite uma divisão clara </a:t>
-            </a:r>
-            <a:r>
-              <a:rPr lang="en-US" sz="3255">
-                <a:solidFill>
-                  <a:srgbClr val="EDE8EA"/>
-                </a:solidFill>
-                <a:latin typeface="Open Sauce"/>
-                <a:ea typeface="Open Sauce"/>
-                <a:cs typeface="Open Sauce"/>
-                <a:sym typeface="Open Sauce"/>
-              </a:rPr>
-              <a:t>entre src/ (produção) e tests/ (validação). </a:t>
+              <a:t>da na experiência do utilizador, que educa as mulheres sobre o seu corpo e dá recomendações de profissionais para os seus sintomas.</a:t>
             </a:r>
           </a:p>
           <a:p>

</xml_diff>